<commit_message>
Audit all module records and rebuild the survey around agent construction
</commit_message>
<xml_diff>
--- a/artifacts/active/Figure7_infrastructure_rsi_style_grouped.pptx
+++ b/artifacts/active/Figure7_infrastructure_rsi_style_grouped.pptx
@@ -1080,7 +1080,7 @@
               </a:extLst>
             </p:cNvPr>
             <p:cNvSpPr>
-              <a:spLocks xmlns:a="http://schemas.openxmlformats.org/drawingml/2006/main" noGrp="1"/>
+              <a:spLocks xmlns:a="http://schemas.openxmlformats.org/drawingml/2006/main"/>
             </p:cNvSpPr>
             <p:nvPr/>
           </p:nvSpPr>
@@ -1136,7 +1136,7 @@
               </a:extLst>
             </p:cNvPr>
             <p:cNvSpPr>
-              <a:spLocks xmlns:a="http://schemas.openxmlformats.org/drawingml/2006/main" noGrp="1"/>
+              <a:spLocks xmlns:a="http://schemas.openxmlformats.org/drawingml/2006/main"/>
             </p:cNvSpPr>
             <p:nvPr/>
           </p:nvSpPr>
@@ -1207,7 +1207,7 @@
               </a:extLst>
             </p:cNvPr>
             <p:cNvSpPr>
-              <a:spLocks xmlns:a="http://schemas.openxmlformats.org/drawingml/2006/main" noGrp="1"/>
+              <a:spLocks xmlns:a="http://schemas.openxmlformats.org/drawingml/2006/main"/>
             </p:cNvSpPr>
             <p:nvPr/>
           </p:nvSpPr>
@@ -1242,7 +1242,7 @@
               </a:extLst>
             </p:cNvPr>
             <p:cNvSpPr>
-              <a:spLocks xmlns:a="http://schemas.openxmlformats.org/drawingml/2006/main" noGrp="1"/>
+              <a:spLocks xmlns:a="http://schemas.openxmlformats.org/drawingml/2006/main"/>
             </p:cNvSpPr>
             <p:nvPr/>
           </p:nvSpPr>
@@ -1298,7 +1298,7 @@
               </a:extLst>
             </p:cNvPr>
             <p:cNvSpPr>
-              <a:spLocks xmlns:a="http://schemas.openxmlformats.org/drawingml/2006/main" noGrp="1"/>
+              <a:spLocks xmlns:a="http://schemas.openxmlformats.org/drawingml/2006/main"/>
             </p:cNvSpPr>
             <p:nvPr/>
           </p:nvSpPr>
@@ -1354,7 +1354,7 @@
               </a:extLst>
             </p:cNvPr>
             <p:cNvSpPr>
-              <a:spLocks xmlns:a="http://schemas.openxmlformats.org/drawingml/2006/main" noGrp="1"/>
+              <a:spLocks xmlns:a="http://schemas.openxmlformats.org/drawingml/2006/main"/>
             </p:cNvSpPr>
             <p:nvPr/>
           </p:nvSpPr>
@@ -1389,7 +1389,7 @@
               </a:extLst>
             </p:cNvPr>
             <p:cNvSpPr>
-              <a:spLocks xmlns:a="http://schemas.openxmlformats.org/drawingml/2006/main" noGrp="1"/>
+              <a:spLocks xmlns:a="http://schemas.openxmlformats.org/drawingml/2006/main"/>
             </p:cNvSpPr>
             <p:nvPr/>
           </p:nvSpPr>
@@ -1445,7 +1445,7 @@
               </a:extLst>
             </p:cNvPr>
             <p:cNvSpPr>
-              <a:spLocks xmlns:a="http://schemas.openxmlformats.org/drawingml/2006/main" noGrp="1"/>
+              <a:spLocks xmlns:a="http://schemas.openxmlformats.org/drawingml/2006/main"/>
             </p:cNvSpPr>
             <p:nvPr/>
           </p:nvSpPr>
@@ -1501,7 +1501,7 @@
               </a:extLst>
             </p:cNvPr>
             <p:cNvSpPr>
-              <a:spLocks xmlns:a="http://schemas.openxmlformats.org/drawingml/2006/main" noGrp="1"/>
+              <a:spLocks xmlns:a="http://schemas.openxmlformats.org/drawingml/2006/main"/>
             </p:cNvSpPr>
             <p:nvPr/>
           </p:nvSpPr>
@@ -1536,7 +1536,7 @@
               </a:extLst>
             </p:cNvPr>
             <p:cNvSpPr>
-              <a:spLocks xmlns:a="http://schemas.openxmlformats.org/drawingml/2006/main" noGrp="1"/>
+              <a:spLocks xmlns:a="http://schemas.openxmlformats.org/drawingml/2006/main"/>
             </p:cNvSpPr>
             <p:nvPr/>
           </p:nvSpPr>
@@ -1577,7 +1577,7 @@
                   <a:ea typeface="Times New Roman"/>
                   <a:cs typeface="Times New Roman"/>
                 </a:rPr>
-                <a:t>Skill simulators</a:t>
+                <a:t>Analytical operations</a:t>
               </a:r>
             </a:p>
           </p:txBody>
@@ -1592,7 +1592,7 @@
               </a:extLst>
             </p:cNvPr>
             <p:cNvSpPr>
-              <a:spLocks xmlns:a="http://schemas.openxmlformats.org/drawingml/2006/main" noGrp="1"/>
+              <a:spLocks xmlns:a="http://schemas.openxmlformats.org/drawingml/2006/main"/>
             </p:cNvSpPr>
             <p:nvPr/>
           </p:nvSpPr>
@@ -1648,7 +1648,7 @@
               </a:extLst>
             </p:cNvPr>
             <p:cNvSpPr>
-              <a:spLocks xmlns:a="http://schemas.openxmlformats.org/drawingml/2006/main" noGrp="1"/>
+              <a:spLocks xmlns:a="http://schemas.openxmlformats.org/drawingml/2006/main"/>
             </p:cNvSpPr>
             <p:nvPr/>
           </p:nvSpPr>
@@ -1683,7 +1683,7 @@
               </a:extLst>
             </p:cNvPr>
             <p:cNvSpPr>
-              <a:spLocks xmlns:a="http://schemas.openxmlformats.org/drawingml/2006/main" noGrp="1"/>
+              <a:spLocks xmlns:a="http://schemas.openxmlformats.org/drawingml/2006/main"/>
             </p:cNvSpPr>
             <p:nvPr/>
           </p:nvSpPr>
@@ -1739,7 +1739,7 @@
               </a:extLst>
             </p:cNvPr>
             <p:cNvSpPr>
-              <a:spLocks xmlns:a="http://schemas.openxmlformats.org/drawingml/2006/main" noGrp="1"/>
+              <a:spLocks xmlns:a="http://schemas.openxmlformats.org/drawingml/2006/main"/>
             </p:cNvSpPr>
             <p:nvPr/>
           </p:nvSpPr>
@@ -1795,7 +1795,7 @@
               </a:extLst>
             </p:cNvPr>
             <p:cNvSpPr>
-              <a:spLocks xmlns:a="http://schemas.openxmlformats.org/drawingml/2006/main" noGrp="1"/>
+              <a:spLocks xmlns:a="http://schemas.openxmlformats.org/drawingml/2006/main"/>
             </p:cNvSpPr>
             <p:nvPr/>
           </p:nvSpPr>
@@ -1830,7 +1830,7 @@
               </a:extLst>
             </p:cNvPr>
             <p:cNvSpPr>
-              <a:spLocks xmlns:a="http://schemas.openxmlformats.org/drawingml/2006/main" noGrp="1"/>
+              <a:spLocks xmlns:a="http://schemas.openxmlformats.org/drawingml/2006/main"/>
             </p:cNvSpPr>
             <p:nvPr/>
           </p:nvSpPr>
@@ -1886,7 +1886,7 @@
               </a:extLst>
             </p:cNvPr>
             <p:cNvSpPr>
-              <a:spLocks xmlns:a="http://schemas.openxmlformats.org/drawingml/2006/main" noGrp="1"/>
+              <a:spLocks xmlns:a="http://schemas.openxmlformats.org/drawingml/2006/main"/>
             </p:cNvSpPr>
             <p:nvPr/>
           </p:nvSpPr>
@@ -1942,7 +1942,7 @@
               </a:extLst>
             </p:cNvPr>
             <p:cNvSpPr>
-              <a:spLocks xmlns:a="http://schemas.openxmlformats.org/drawingml/2006/main" noGrp="1"/>
+              <a:spLocks xmlns:a="http://schemas.openxmlformats.org/drawingml/2006/main"/>
             </p:cNvSpPr>
             <p:nvPr/>
           </p:nvSpPr>
@@ -1977,7 +1977,7 @@
               </a:extLst>
             </p:cNvPr>
             <p:cNvSpPr>
-              <a:spLocks xmlns:a="http://schemas.openxmlformats.org/drawingml/2006/main" noGrp="1"/>
+              <a:spLocks xmlns:a="http://schemas.openxmlformats.org/drawingml/2006/main"/>
             </p:cNvSpPr>
             <p:nvPr/>
           </p:nvSpPr>
@@ -2033,7 +2033,7 @@
               </a:extLst>
             </p:cNvPr>
             <p:cNvSpPr>
-              <a:spLocks xmlns:a="http://schemas.openxmlformats.org/drawingml/2006/main" noGrp="1"/>
+              <a:spLocks xmlns:a="http://schemas.openxmlformats.org/drawingml/2006/main"/>
             </p:cNvSpPr>
             <p:nvPr/>
           </p:nvSpPr>
@@ -2089,7 +2089,7 @@
               </a:extLst>
             </p:cNvPr>
             <p:cNvSpPr>
-              <a:spLocks xmlns:a="http://schemas.openxmlformats.org/drawingml/2006/main" noGrp="1"/>
+              <a:spLocks xmlns:a="http://schemas.openxmlformats.org/drawingml/2006/main"/>
             </p:cNvSpPr>
             <p:nvPr/>
           </p:nvSpPr>
@@ -2124,7 +2124,7 @@
               </a:extLst>
             </p:cNvPr>
             <p:cNvSpPr>
-              <a:spLocks xmlns:a="http://schemas.openxmlformats.org/drawingml/2006/main" noGrp="1"/>
+              <a:spLocks xmlns:a="http://schemas.openxmlformats.org/drawingml/2006/main"/>
             </p:cNvSpPr>
             <p:nvPr/>
           </p:nvSpPr>
@@ -2180,7 +2180,7 @@
               </a:extLst>
             </p:cNvPr>
             <p:cNvSpPr>
-              <a:spLocks xmlns:a="http://schemas.openxmlformats.org/drawingml/2006/main" noGrp="1"/>
+              <a:spLocks xmlns:a="http://schemas.openxmlformats.org/drawingml/2006/main"/>
             </p:cNvSpPr>
             <p:nvPr/>
           </p:nvSpPr>
@@ -2236,7 +2236,7 @@
               </a:extLst>
             </p:cNvPr>
             <p:cNvSpPr>
-              <a:spLocks xmlns:a="http://schemas.openxmlformats.org/drawingml/2006/main" noGrp="1"/>
+              <a:spLocks xmlns:a="http://schemas.openxmlformats.org/drawingml/2006/main"/>
             </p:cNvSpPr>
             <p:nvPr/>
           </p:nvSpPr>
@@ -2271,7 +2271,7 @@
               </a:extLst>
             </p:cNvPr>
             <p:cNvSpPr>
-              <a:spLocks xmlns:a="http://schemas.openxmlformats.org/drawingml/2006/main" noGrp="1"/>
+              <a:spLocks xmlns:a="http://schemas.openxmlformats.org/drawingml/2006/main"/>
             </p:cNvSpPr>
             <p:nvPr/>
           </p:nvSpPr>
@@ -2327,7 +2327,7 @@
               </a:extLst>
             </p:cNvPr>
             <p:cNvSpPr>
-              <a:spLocks xmlns:a="http://schemas.openxmlformats.org/drawingml/2006/main" noGrp="1"/>
+              <a:spLocks xmlns:a="http://schemas.openxmlformats.org/drawingml/2006/main"/>
             </p:cNvSpPr>
             <p:nvPr/>
           </p:nvSpPr>
@@ -2383,7 +2383,7 @@
               </a:extLst>
             </p:cNvPr>
             <p:cNvSpPr>
-              <a:spLocks xmlns:a="http://schemas.openxmlformats.org/drawingml/2006/main" noGrp="1"/>
+              <a:spLocks xmlns:a="http://schemas.openxmlformats.org/drawingml/2006/main"/>
             </p:cNvSpPr>
             <p:nvPr/>
           </p:nvSpPr>
@@ -2418,7 +2418,7 @@
               </a:extLst>
             </p:cNvPr>
             <p:cNvSpPr>
-              <a:spLocks xmlns:a="http://schemas.openxmlformats.org/drawingml/2006/main" noGrp="1"/>
+              <a:spLocks xmlns:a="http://schemas.openxmlformats.org/drawingml/2006/main"/>
             </p:cNvSpPr>
             <p:nvPr/>
           </p:nvSpPr>
@@ -2474,7 +2474,7 @@
               </a:extLst>
             </p:cNvPr>
             <p:cNvSpPr>
-              <a:spLocks xmlns:a="http://schemas.openxmlformats.org/drawingml/2006/main" noGrp="1"/>
+              <a:spLocks xmlns:a="http://schemas.openxmlformats.org/drawingml/2006/main"/>
             </p:cNvSpPr>
             <p:nvPr/>
           </p:nvSpPr>
@@ -2530,7 +2530,7 @@
               </a:extLst>
             </p:cNvPr>
             <p:cNvSpPr>
-              <a:spLocks xmlns:a="http://schemas.openxmlformats.org/drawingml/2006/main" noGrp="1"/>
+              <a:spLocks xmlns:a="http://schemas.openxmlformats.org/drawingml/2006/main"/>
             </p:cNvSpPr>
             <p:nvPr/>
           </p:nvSpPr>
@@ -2565,7 +2565,7 @@
               </a:extLst>
             </p:cNvPr>
             <p:cNvSpPr>
-              <a:spLocks xmlns:a="http://schemas.openxmlformats.org/drawingml/2006/main" noGrp="1"/>
+              <a:spLocks xmlns:a="http://schemas.openxmlformats.org/drawingml/2006/main"/>
             </p:cNvSpPr>
             <p:nvPr/>
           </p:nvSpPr>
@@ -2621,7 +2621,7 @@
               </a:extLst>
             </p:cNvPr>
             <p:cNvSpPr>
-              <a:spLocks xmlns:a="http://schemas.openxmlformats.org/drawingml/2006/main" noGrp="1"/>
+              <a:spLocks xmlns:a="http://schemas.openxmlformats.org/drawingml/2006/main"/>
             </p:cNvSpPr>
             <p:nvPr/>
           </p:nvSpPr>
@@ -2677,7 +2677,7 @@
               </a:extLst>
             </p:cNvPr>
             <p:cNvSpPr>
-              <a:spLocks xmlns:a="http://schemas.openxmlformats.org/drawingml/2006/main" noGrp="1"/>
+              <a:spLocks xmlns:a="http://schemas.openxmlformats.org/drawingml/2006/main"/>
             </p:cNvSpPr>
             <p:nvPr/>
           </p:nvSpPr>
@@ -2712,7 +2712,7 @@
               </a:extLst>
             </p:cNvPr>
             <p:cNvSpPr>
-              <a:spLocks xmlns:a="http://schemas.openxmlformats.org/drawingml/2006/main" noGrp="1"/>
+              <a:spLocks xmlns:a="http://schemas.openxmlformats.org/drawingml/2006/main"/>
             </p:cNvSpPr>
             <p:nvPr/>
           </p:nvSpPr>
@@ -2768,7 +2768,7 @@
               </a:extLst>
             </p:cNvPr>
             <p:cNvSpPr>
-              <a:spLocks xmlns:a="http://schemas.openxmlformats.org/drawingml/2006/main" noGrp="1"/>
+              <a:spLocks xmlns:a="http://schemas.openxmlformats.org/drawingml/2006/main"/>
             </p:cNvSpPr>
             <p:nvPr/>
           </p:nvSpPr>
@@ -2824,7 +2824,7 @@
               </a:extLst>
             </p:cNvPr>
             <p:cNvSpPr>
-              <a:spLocks xmlns:a="http://schemas.openxmlformats.org/drawingml/2006/main" noGrp="1"/>
+              <a:spLocks xmlns:a="http://schemas.openxmlformats.org/drawingml/2006/main"/>
             </p:cNvSpPr>
             <p:nvPr/>
           </p:nvSpPr>
@@ -2859,7 +2859,7 @@
               </a:extLst>
             </p:cNvPr>
             <p:cNvSpPr>
-              <a:spLocks xmlns:a="http://schemas.openxmlformats.org/drawingml/2006/main" noGrp="1"/>
+              <a:spLocks xmlns:a="http://schemas.openxmlformats.org/drawingml/2006/main"/>
             </p:cNvSpPr>
             <p:nvPr/>
           </p:nvSpPr>
@@ -2915,7 +2915,7 @@
               </a:extLst>
             </p:cNvPr>
             <p:cNvSpPr>
-              <a:spLocks xmlns:a="http://schemas.openxmlformats.org/drawingml/2006/main" noGrp="1"/>
+              <a:spLocks xmlns:a="http://schemas.openxmlformats.org/drawingml/2006/main"/>
             </p:cNvSpPr>
             <p:nvPr/>
           </p:nvSpPr>
@@ -2971,7 +2971,7 @@
               </a:extLst>
             </p:cNvPr>
             <p:cNvSpPr>
-              <a:spLocks xmlns:a="http://schemas.openxmlformats.org/drawingml/2006/main" noGrp="1"/>
+              <a:spLocks xmlns:a="http://schemas.openxmlformats.org/drawingml/2006/main"/>
             </p:cNvSpPr>
             <p:nvPr/>
           </p:nvSpPr>
@@ -3006,7 +3006,7 @@
               </a:extLst>
             </p:cNvPr>
             <p:cNvSpPr>
-              <a:spLocks xmlns:a="http://schemas.openxmlformats.org/drawingml/2006/main" noGrp="1"/>
+              <a:spLocks xmlns:a="http://schemas.openxmlformats.org/drawingml/2006/main"/>
             </p:cNvSpPr>
             <p:nvPr/>
           </p:nvSpPr>
@@ -3062,7 +3062,7 @@
               </a:extLst>
             </p:cNvPr>
             <p:cNvSpPr>
-              <a:spLocks xmlns:a="http://schemas.openxmlformats.org/drawingml/2006/main" noGrp="1"/>
+              <a:spLocks xmlns:a="http://schemas.openxmlformats.org/drawingml/2006/main"/>
             </p:cNvSpPr>
             <p:nvPr/>
           </p:nvSpPr>
@@ -3118,7 +3118,7 @@
               </a:extLst>
             </p:cNvPr>
             <p:cNvSpPr>
-              <a:spLocks xmlns:a="http://schemas.openxmlformats.org/drawingml/2006/main" noGrp="1"/>
+              <a:spLocks xmlns:a="http://schemas.openxmlformats.org/drawingml/2006/main"/>
             </p:cNvSpPr>
             <p:nvPr/>
           </p:nvSpPr>
@@ -3153,7 +3153,7 @@
               </a:extLst>
             </p:cNvPr>
             <p:cNvSpPr>
-              <a:spLocks xmlns:a="http://schemas.openxmlformats.org/drawingml/2006/main" noGrp="1"/>
+              <a:spLocks xmlns:a="http://schemas.openxmlformats.org/drawingml/2006/main"/>
             </p:cNvSpPr>
             <p:nvPr/>
           </p:nvSpPr>
@@ -3209,7 +3209,7 @@
               </a:extLst>
             </p:cNvPr>
             <p:cNvSpPr>
-              <a:spLocks xmlns:a="http://schemas.openxmlformats.org/drawingml/2006/main" noGrp="1"/>
+              <a:spLocks xmlns:a="http://schemas.openxmlformats.org/drawingml/2006/main"/>
             </p:cNvSpPr>
             <p:nvPr/>
           </p:nvSpPr>
@@ -3265,7 +3265,7 @@
               </a:extLst>
             </p:cNvPr>
             <p:cNvSpPr>
-              <a:spLocks xmlns:a="http://schemas.openxmlformats.org/drawingml/2006/main" noGrp="1"/>
+              <a:spLocks xmlns:a="http://schemas.openxmlformats.org/drawingml/2006/main"/>
             </p:cNvSpPr>
             <p:nvPr/>
           </p:nvSpPr>
@@ -3296,7 +3296,7 @@
               </a:extLst>
             </p:cNvPr>
             <p:cNvSpPr>
-              <a:spLocks xmlns:a="http://schemas.openxmlformats.org/drawingml/2006/main" noGrp="1"/>
+              <a:spLocks xmlns:a="http://schemas.openxmlformats.org/drawingml/2006/main"/>
             </p:cNvSpPr>
             <p:nvPr/>
           </p:nvSpPr>
@@ -3327,7 +3327,7 @@
               </a:extLst>
             </p:cNvPr>
             <p:cNvSpPr>
-              <a:spLocks xmlns:a="http://schemas.openxmlformats.org/drawingml/2006/main" noGrp="1"/>
+              <a:spLocks xmlns:a="http://schemas.openxmlformats.org/drawingml/2006/main"/>
             </p:cNvSpPr>
             <p:nvPr/>
           </p:nvSpPr>
@@ -3358,7 +3358,7 @@
               </a:extLst>
             </p:cNvPr>
             <p:cNvSpPr>
-              <a:spLocks xmlns:a="http://schemas.openxmlformats.org/drawingml/2006/main" noGrp="1"/>
+              <a:spLocks xmlns:a="http://schemas.openxmlformats.org/drawingml/2006/main"/>
             </p:cNvSpPr>
             <p:nvPr/>
           </p:nvSpPr>
@@ -3393,7 +3393,7 @@
               </a:extLst>
             </p:cNvPr>
             <p:cNvSpPr>
-              <a:spLocks xmlns:a="http://schemas.openxmlformats.org/drawingml/2006/main" noGrp="1"/>
+              <a:spLocks xmlns:a="http://schemas.openxmlformats.org/drawingml/2006/main"/>
             </p:cNvSpPr>
             <p:nvPr/>
           </p:nvSpPr>
@@ -3449,7 +3449,7 @@
               </a:extLst>
             </p:cNvPr>
             <p:cNvSpPr>
-              <a:spLocks xmlns:a="http://schemas.openxmlformats.org/drawingml/2006/main" noGrp="1"/>
+              <a:spLocks xmlns:a="http://schemas.openxmlformats.org/drawingml/2006/main"/>
             </p:cNvSpPr>
             <p:nvPr/>
           </p:nvSpPr>
@@ -3505,7 +3505,7 @@
               </a:extLst>
             </p:cNvPr>
             <p:cNvSpPr>
-              <a:spLocks xmlns:a="http://schemas.openxmlformats.org/drawingml/2006/main" noGrp="1"/>
+              <a:spLocks xmlns:a="http://schemas.openxmlformats.org/drawingml/2006/main"/>
             </p:cNvSpPr>
             <p:nvPr/>
           </p:nvSpPr>
@@ -3540,7 +3540,7 @@
               </a:extLst>
             </p:cNvPr>
             <p:cNvSpPr>
-              <a:spLocks xmlns:a="http://schemas.openxmlformats.org/drawingml/2006/main" noGrp="1"/>
+              <a:spLocks xmlns:a="http://schemas.openxmlformats.org/drawingml/2006/main"/>
             </p:cNvSpPr>
             <p:nvPr/>
           </p:nvSpPr>
@@ -3596,7 +3596,7 @@
               </a:extLst>
             </p:cNvPr>
             <p:cNvSpPr>
-              <a:spLocks xmlns:a="http://schemas.openxmlformats.org/drawingml/2006/main" noGrp="1"/>
+              <a:spLocks xmlns:a="http://schemas.openxmlformats.org/drawingml/2006/main"/>
             </p:cNvSpPr>
             <p:nvPr/>
           </p:nvSpPr>
@@ -3652,7 +3652,7 @@
               </a:extLst>
             </p:cNvPr>
             <p:cNvSpPr>
-              <a:spLocks xmlns:a="http://schemas.openxmlformats.org/drawingml/2006/main" noGrp="1"/>
+              <a:spLocks xmlns:a="http://schemas.openxmlformats.org/drawingml/2006/main"/>
             </p:cNvSpPr>
             <p:nvPr/>
           </p:nvSpPr>
@@ -3687,7 +3687,7 @@
               </a:extLst>
             </p:cNvPr>
             <p:cNvSpPr>
-              <a:spLocks xmlns:a="http://schemas.openxmlformats.org/drawingml/2006/main" noGrp="1"/>
+              <a:spLocks xmlns:a="http://schemas.openxmlformats.org/drawingml/2006/main"/>
             </p:cNvSpPr>
             <p:nvPr/>
           </p:nvSpPr>
@@ -3728,7 +3728,7 @@
                   <a:ea typeface="Times New Roman"/>
                   <a:cs typeface="Times New Roman"/>
                 </a:rPr>
-                <a:t>Holistic score</a:t>
+                <a:t>Evaluation report</a:t>
               </a:r>
             </a:p>
           </p:txBody>
@@ -3743,7 +3743,7 @@
               </a:extLst>
             </p:cNvPr>
             <p:cNvSpPr>
-              <a:spLocks xmlns:a="http://schemas.openxmlformats.org/drawingml/2006/main" noGrp="1"/>
+              <a:spLocks xmlns:a="http://schemas.openxmlformats.org/drawingml/2006/main"/>
             </p:cNvSpPr>
             <p:nvPr/>
           </p:nvSpPr>
@@ -3799,7 +3799,7 @@
               </a:extLst>
             </p:cNvPr>
             <p:cNvSpPr>
-              <a:spLocks xmlns:a="http://schemas.openxmlformats.org/drawingml/2006/main" noGrp="1"/>
+              <a:spLocks xmlns:a="http://schemas.openxmlformats.org/drawingml/2006/main"/>
             </p:cNvSpPr>
             <p:nvPr/>
           </p:nvSpPr>
@@ -3830,7 +3830,7 @@
               </a:extLst>
             </p:cNvPr>
             <p:cNvSpPr>
-              <a:spLocks xmlns:a="http://schemas.openxmlformats.org/drawingml/2006/main" noGrp="1"/>
+              <a:spLocks xmlns:a="http://schemas.openxmlformats.org/drawingml/2006/main"/>
             </p:cNvSpPr>
             <p:nvPr/>
           </p:nvSpPr>
@@ -3861,7 +3861,7 @@
               </a:extLst>
             </p:cNvPr>
             <p:cNvSpPr>
-              <a:spLocks xmlns:a="http://schemas.openxmlformats.org/drawingml/2006/main" noGrp="1"/>
+              <a:spLocks xmlns:a="http://schemas.openxmlformats.org/drawingml/2006/main"/>
             </p:cNvSpPr>
             <p:nvPr/>
           </p:nvSpPr>

</xml_diff>